<commit_message>
A7 Unit 6: lesson 6.04 (GR.1.1) at 0 findings — sketch the story, mark the square corner, name c: ladders, ramps, screens, a lawn, a kite and will-it-fit, every number our own; board 6 votes only on which length is c (the state's two GR.1.1 misconceptions); the B1G-M ladder lives in the notes; no 3-D. figs: a steep ladder's height label outside the wall; slide sizing survives a label collision
Co-Authored-By: Claude Opus 5.5 <noreply@anthropic.com>
Claude-Session: https://claude.ai/code/session_018Be467MLKJu6DjkSsjpM7D
</commit_message>
<xml_diff>
--- a/a7/build/out/u6/A7 6.03 Pythagorean Theorem - Slides.pptx
+++ b/a7/build/out/u6/A7 6.03 Pythagorean Theorem - Slides.pptx
@@ -4381,7 +4381,7 @@
       </p:sp>
       <p:pic>
         <p:nvPicPr>
-          <p:cNvPr id="9" name="Picture 8" descr="g314373f1c6e44b6c.png"/>
+          <p:cNvPr id="9" name="Picture 8" descr="g1605b09377360d9a.png"/>
           <p:cNvPicPr>
             <a:picLocks noChangeAspect="1"/>
           </p:cNvPicPr>
@@ -4395,8 +4395,8 @@
         </p:blipFill>
         <p:spPr>
           <a:xfrm>
-            <a:off x="5166359" y="2276458"/>
-            <a:ext cx="1828800" cy="2597386"/>
+            <a:off x="5175503" y="2276458"/>
+            <a:ext cx="1810512" cy="2552393"/>
           </a:xfrm>
           <a:prstGeom prst="rect">
             <a:avLst/>
@@ -4411,7 +4411,7 @@
         </p:nvSpPr>
         <p:spPr>
           <a:xfrm>
-            <a:off x="777240" y="5203029"/>
+            <a:off x="777240" y="5158035"/>
             <a:ext cx="10607040" cy="429370"/>
           </a:xfrm>
           <a:prstGeom prst="rect">
@@ -15625,7 +15625,7 @@
       </p:cxnSp>
       <p:pic>
         <p:nvPicPr>
-          <p:cNvPr id="10" name="Picture 9" descr="gd52f9f29f97d9dec.png"/>
+          <p:cNvPr id="10" name="Picture 9" descr="g58aa5bffac20af42.png"/>
           <p:cNvPicPr>
             <a:picLocks noChangeAspect="1"/>
           </p:cNvPicPr>
@@ -15639,8 +15639,8 @@
         </p:blipFill>
         <p:spPr>
           <a:xfrm>
-            <a:off x="3968496" y="1993392"/>
-            <a:ext cx="4224528" cy="2199719"/>
+            <a:off x="3973068" y="1993392"/>
+            <a:ext cx="4215384" cy="2194957"/>
           </a:xfrm>
           <a:prstGeom prst="rect">
             <a:avLst/>
@@ -15663,7 +15663,7 @@
         </p:blipFill>
         <p:spPr>
           <a:xfrm>
-            <a:off x="987552" y="4385135"/>
+            <a:off x="987552" y="4380373"/>
             <a:ext cx="1929384" cy="341376"/>
           </a:xfrm>
           <a:prstGeom prst="rect">
@@ -15679,7 +15679,7 @@
         </p:nvSpPr>
         <p:spPr>
           <a:xfrm>
-            <a:off x="987552" y="5070935"/>
+            <a:off x="987552" y="5066173"/>
             <a:ext cx="10131551" cy="950976"/>
           </a:xfrm>
           <a:prstGeom prst="rect">

</xml_diff>